<commit_message>
Update manuscript layout and release artifact v1.0.7
</commit_message>
<xml_diff>
--- a/manuscript/figures/fig_system_workflow_simplified_editable.pptx
+++ b/manuscript/figures/fig_system_workflow_simplified_editable.pptx
@@ -7151,7 +7151,7 @@
               </a:defRPr>
             </a:pPr>
             <a:r>
-              <a:rPr b="1">
+              <a:rPr b="1" sz="1263">
                 <a:latin typeface="Arial Narrow"/>
                 <a:ea typeface="Arial Narrow"/>
                 <a:cs typeface="Arial Narrow"/>
@@ -8594,7 +8594,7 @@
               </a:defRPr>
             </a:pPr>
             <a:r>
-              <a:rPr b="1">
+              <a:rPr b="1" sz="1263">
                 <a:latin typeface="Arial Narrow"/>
                 <a:ea typeface="Arial Narrow"/>
                 <a:cs typeface="Arial Narrow"/>
@@ -10037,7 +10037,7 @@
               </a:defRPr>
             </a:pPr>
             <a:r>
-              <a:rPr b="1">
+              <a:rPr b="1" sz="1263">
                 <a:latin typeface="Arial Narrow"/>
                 <a:ea typeface="Arial Narrow"/>
                 <a:cs typeface="Arial Narrow"/>
@@ -11480,7 +11480,7 @@
               </a:defRPr>
             </a:pPr>
             <a:r>
-              <a:rPr b="1">
+              <a:rPr b="1" sz="1263">
                 <a:latin typeface="Arial Narrow"/>
                 <a:ea typeface="Arial Narrow"/>
                 <a:cs typeface="Arial Narrow"/>
@@ -12923,7 +12923,7 @@
               </a:defRPr>
             </a:pPr>
             <a:r>
-              <a:rPr b="1">
+              <a:rPr b="1" sz="1263">
                 <a:latin typeface="Arial Narrow"/>
                 <a:ea typeface="Arial Narrow"/>
                 <a:cs typeface="Arial Narrow"/>
@@ -14366,7 +14366,7 @@
               </a:defRPr>
             </a:pPr>
             <a:r>
-              <a:rPr b="1">
+              <a:rPr b="1" sz="1263">
                 <a:latin typeface="Arial Narrow"/>
                 <a:ea typeface="Arial Narrow"/>
                 <a:cs typeface="Arial Narrow"/>
@@ -15950,7 +15950,7 @@
               </a:defRPr>
             </a:pPr>
             <a:r>
-              <a:rPr b="1">
+              <a:rPr b="1" sz="1205">
                 <a:latin typeface="Arial Narrow"/>
                 <a:ea typeface="Arial Narrow"/>
                 <a:cs typeface="Arial Narrow"/>
@@ -16091,7 +16091,7 @@
               </a:defRPr>
             </a:pPr>
             <a:r>
-              <a:rPr b="1">
+              <a:rPr b="1" sz="1205">
                 <a:latin typeface="Arial Narrow"/>
                 <a:ea typeface="Arial Narrow"/>
                 <a:cs typeface="Arial Narrow"/>
@@ -16232,7 +16232,7 @@
               </a:defRPr>
             </a:pPr>
             <a:r>
-              <a:rPr b="1">
+              <a:rPr b="1" sz="1205">
                 <a:latin typeface="Arial Narrow"/>
                 <a:ea typeface="Arial Narrow"/>
                 <a:cs typeface="Arial Narrow"/>
@@ -16373,7 +16373,7 @@
               </a:defRPr>
             </a:pPr>
             <a:r>
-              <a:rPr b="1">
+              <a:rPr b="1" sz="1205">
                 <a:latin typeface="Arial Narrow"/>
                 <a:ea typeface="Arial Narrow"/>
                 <a:cs typeface="Arial Narrow"/>
@@ -16514,7 +16514,7 @@
               </a:defRPr>
             </a:pPr>
             <a:r>
-              <a:rPr b="1">
+              <a:rPr b="1" sz="1205">
                 <a:latin typeface="Arial Narrow"/>
                 <a:ea typeface="Arial Narrow"/>
                 <a:cs typeface="Arial Narrow"/>
@@ -17549,7 +17549,7 @@
               </a:defRPr>
             </a:pPr>
             <a:r>
-              <a:rPr b="1">
+              <a:rPr b="1" sz="1205">
                 <a:latin typeface="Arial Narrow"/>
                 <a:ea typeface="Arial Narrow"/>
                 <a:cs typeface="Arial Narrow"/>
@@ -17886,7 +17886,7 @@
               </a:defRPr>
             </a:pPr>
             <a:r>
-              <a:rPr b="1">
+              <a:rPr b="1" sz="1205">
                 <a:latin typeface="Arial Narrow"/>
                 <a:ea typeface="Arial Narrow"/>
                 <a:cs typeface="Arial Narrow"/>
@@ -18027,7 +18027,7 @@
               </a:defRPr>
             </a:pPr>
             <a:r>
-              <a:rPr b="1">
+              <a:rPr b="1" sz="1205">
                 <a:latin typeface="Arial Narrow"/>
                 <a:ea typeface="Arial Narrow"/>
                 <a:cs typeface="Arial Narrow"/>
@@ -18975,7 +18975,7 @@
               </a:defRPr>
             </a:pPr>
             <a:r>
-              <a:rPr sz="1013" b="1">
+              <a:rPr sz="976" b="1">
                 <a:latin typeface="Arial Narrow"/>
                 <a:ea typeface="Arial Narrow"/>
                 <a:cs typeface="Arial Narrow"/>
@@ -19005,7 +19005,7 @@
               </a:defRPr>
             </a:pPr>
             <a:r>
-              <a:rPr sz="1013" b="1">
+              <a:rPr sz="976" b="1">
                 <a:latin typeface="Arial Narrow"/>
                 <a:ea typeface="Arial Narrow"/>
                 <a:cs typeface="Arial Narrow"/>
@@ -19488,8 +19488,8 @@
         </p:nvSpPr>
         <p:spPr>
           <a:xfrm xmlns:a="http://schemas.openxmlformats.org/drawingml/2006/main">
-            <a:off x="4090735" y="4263475"/>
-            <a:ext cx="619808" cy="830831"/>
+            <a:off x="4090736" y="4263475"/>
+            <a:ext cx="670851" cy="830831"/>
           </a:xfrm>
           <a:prstGeom xmlns:a="http://schemas.openxmlformats.org/drawingml/2006/main" prst="roundRect">
             <a:avLst>
@@ -19545,7 +19545,7 @@
         </p:nvSpPr>
         <p:spPr>
           <a:xfrm xmlns:a="http://schemas.openxmlformats.org/drawingml/2006/main">
-            <a:off x="4112611" y="4314490"/>
+            <a:off x="4138133" y="4314490"/>
             <a:ext cx="576057" cy="318516"/>
           </a:xfrm>
           <a:prstGeom xmlns:a="http://schemas.openxmlformats.org/drawingml/2006/main" prst="rect">
@@ -19716,8 +19716,8 @@
         </p:nvSpPr>
         <p:spPr>
           <a:xfrm xmlns:a="http://schemas.openxmlformats.org/drawingml/2006/main">
-            <a:off x="4747003" y="4263475"/>
-            <a:ext cx="619808" cy="830831"/>
+            <a:off x="4798047" y="4263475"/>
+            <a:ext cx="670851" cy="830831"/>
           </a:xfrm>
           <a:prstGeom xmlns:a="http://schemas.openxmlformats.org/drawingml/2006/main" prst="roundRect">
             <a:avLst>
@@ -19773,7 +19773,7 @@
         </p:nvSpPr>
         <p:spPr>
           <a:xfrm xmlns:a="http://schemas.openxmlformats.org/drawingml/2006/main">
-            <a:off x="4768879" y="4314490"/>
+            <a:off x="4845444" y="4314490"/>
             <a:ext cx="576057" cy="318516"/>
           </a:xfrm>
           <a:prstGeom xmlns:a="http://schemas.openxmlformats.org/drawingml/2006/main" prst="rect">
@@ -19944,8 +19944,8 @@
         </p:nvSpPr>
         <p:spPr>
           <a:xfrm xmlns:a="http://schemas.openxmlformats.org/drawingml/2006/main">
-            <a:off x="5403271" y="4263475"/>
-            <a:ext cx="911483" cy="830831"/>
+            <a:off x="5505358" y="4263475"/>
+            <a:ext cx="765645" cy="830831"/>
           </a:xfrm>
           <a:prstGeom xmlns:a="http://schemas.openxmlformats.org/drawingml/2006/main" prst="roundRect">
             <a:avLst>
@@ -20001,8 +20001,8 @@
         </p:nvSpPr>
         <p:spPr>
           <a:xfrm xmlns:a="http://schemas.openxmlformats.org/drawingml/2006/main">
-            <a:off x="5403271" y="4263475"/>
-            <a:ext cx="911483" cy="830831"/>
+            <a:off x="5505358" y="4263475"/>
+            <a:ext cx="765645" cy="830831"/>
           </a:xfrm>
           <a:prstGeom xmlns:a="http://schemas.openxmlformats.org/drawingml/2006/main" prst="rect">
             <a:avLst/>
@@ -20116,7 +20116,7 @@
               </a:defRPr>
             </a:pPr>
             <a:r>
-              <a:rPr b="1">
+              <a:rPr b="1" sz="1435">
                 <a:latin typeface="Arial Narrow"/>
                 <a:ea typeface="Arial Narrow"/>
                 <a:cs typeface="Arial Narrow"/>
@@ -20142,8 +20142,8 @@
         </p:nvSpPr>
         <p:spPr>
           <a:xfrm xmlns:a="http://schemas.openxmlformats.org/drawingml/2006/main">
-            <a:off x="6351213" y="4263475"/>
-            <a:ext cx="707310" cy="830831"/>
+            <a:off x="6307463" y="4263475"/>
+            <a:ext cx="751062" cy="830831"/>
           </a:xfrm>
           <a:prstGeom xmlns:a="http://schemas.openxmlformats.org/drawingml/2006/main" prst="roundRect">
             <a:avLst>
@@ -20199,7 +20199,7 @@
         </p:nvSpPr>
         <p:spPr>
           <a:xfrm xmlns:a="http://schemas.openxmlformats.org/drawingml/2006/main">
-            <a:off x="6373089" y="4314490"/>
+            <a:off x="6351215" y="4314490"/>
             <a:ext cx="663559" cy="318516"/>
           </a:xfrm>
           <a:prstGeom xmlns:a="http://schemas.openxmlformats.org/drawingml/2006/main" prst="rect">
@@ -21668,7 +21668,7 @@
               </a:defRPr>
             </a:pPr>
             <a:r>
-              <a:rPr sz="1065" b="1">
+              <a:rPr sz="1320" b="1">
                 <a:latin typeface="Arial Narrow"/>
                 <a:ea typeface="Arial Narrow"/>
                 <a:cs typeface="Arial Narrow"/>
@@ -21866,7 +21866,7 @@
               </a:defRPr>
             </a:pPr>
             <a:r>
-              <a:rPr b="1">
+              <a:rPr b="1" sz="1263">
                 <a:latin typeface="Arial Narrow"/>
                 <a:ea typeface="Arial Narrow"/>
                 <a:cs typeface="Arial Narrow"/>
@@ -21896,7 +21896,7 @@
               </a:defRPr>
             </a:pPr>
             <a:r>
-              <a:rPr b="1">
+              <a:rPr b="1" sz="1263">
                 <a:latin typeface="Arial Narrow"/>
                 <a:ea typeface="Arial Narrow"/>
                 <a:cs typeface="Arial Narrow"/>
@@ -22322,7 +22322,7 @@
               </a:defRPr>
             </a:pPr>
             <a:r>
-              <a:rPr b="1">
+              <a:rPr b="1" sz="1148">
                 <a:latin typeface="Arial Narrow"/>
                 <a:ea typeface="Arial Narrow"/>
                 <a:cs typeface="Arial Narrow"/>
@@ -23617,7 +23617,7 @@
               </a:defRPr>
             </a:pPr>
             <a:r>
-              <a:rPr b="1">
+              <a:rPr b="1" sz="1320">
                 <a:latin typeface="Arial Narrow"/>
                 <a:ea typeface="Arial Narrow"/>
                 <a:cs typeface="Arial Narrow"/>
@@ -23647,7 +23647,7 @@
               </a:defRPr>
             </a:pPr>
             <a:r>
-              <a:rPr b="1">
+              <a:rPr b="1" sz="1320">
                 <a:latin typeface="Arial Narrow"/>
                 <a:ea typeface="Arial Narrow"/>
                 <a:cs typeface="Arial Narrow"/>
@@ -24043,7 +24043,7 @@
               </a:defRPr>
             </a:pPr>
             <a:r>
-              <a:rPr b="1">
+              <a:rPr b="1" sz="1320">
                 <a:latin typeface="Arial Narrow"/>
                 <a:ea typeface="Arial Narrow"/>
                 <a:cs typeface="Arial Narrow"/>
@@ -24073,7 +24073,7 @@
               </a:defRPr>
             </a:pPr>
             <a:r>
-              <a:rPr b="1">
+              <a:rPr b="1" sz="1320">
                 <a:latin typeface="Arial Narrow"/>
                 <a:ea typeface="Arial Narrow"/>
                 <a:cs typeface="Arial Narrow"/>
@@ -24469,7 +24469,7 @@
               </a:defRPr>
             </a:pPr>
             <a:r>
-              <a:rPr b="1">
+              <a:rPr b="1" sz="1377">
                 <a:latin typeface="Arial Narrow"/>
                 <a:ea typeface="Arial Narrow"/>
                 <a:cs typeface="Arial Narrow"/>

</xml_diff>